<commit_message>
docs: report the net effect, not just the fallback rate
The deck and the docs reported '0 misses, 60% fallback' without ever stating
what that nets out to — which is the first thing a reviewer will ask and the
number the proposal actually committed to validating.

Derived from the same committed JSONs: total suite time across all
non-equivalent mutants, with tia against without. attrs 182.6s -> 98.4s
(46.1%); scrapy 570.0s -> 297.9s (47.7%). When selection happens at all, the
median reduction on that change is 93.6%. Both figures land inside the 40-70%
range the proposal set out to validate, with zero misses.

The one mutant that hung and consumed the 900s timeout is excluded from these
sums and the exclusion is stated: it measures a hang, not a suite run, and
would dominate any mean.
</commit_message>
<xml_diff>
--- a/docs/tia-review-1.pptx
+++ b/docs/tia-review-1.pptx
@@ -1368,7 +1368,7 @@
           <a:p>
             <a:r>
               <a:rPr lang="en-US" dirty="0"/>
-              <a:t>A reviewer who asks 'did you get the 40-70% you targeted?' gets this slide: the distribution, the reason, and what we would do about it.</a:t>
+              <a:t>A reviewer who asks 'did you get the 40-70% you targeted?' gets this slide: 46% and 48% net, the distribution behind it, the reason for the fallbacks, and what we would do about them. When tia does select, the median reduction on that change is 93.6%.</a:t>
             </a:r>
             <a:endParaRPr lang="en-US" dirty="0"/>
           </a:p>
@@ -6851,13 +6851,13 @@
             <a:r>
               <a:rPr lang="en-US" sz="3400" b="1" dirty="0">
                 <a:solidFill>
-                  <a:srgbClr val="C07A1B"/>
+                  <a:srgbClr val="2E7D62"/>
                 </a:solidFill>
                 <a:latin typeface="Cambria" pitchFamily="34" charset="0"/>
                 <a:ea typeface="Cambria" pitchFamily="34" charset="-122"/>
                 <a:cs typeface="Cambria" pitchFamily="34" charset="-120"/>
               </a:rPr>
-              <a:t>59.6%</a:t>
+              <a:t>46% / 48%</a:t>
             </a:r>
             <a:endParaRPr lang="en-US" sz="3400" dirty="0"/>
           </a:p>
@@ -6896,7 +6896,7 @@
                 <a:ea typeface="Calibri" pitchFamily="34" charset="-122"/>
                 <a:cs typeface="Calibri" pitchFamily="34" charset="-120"/>
               </a:rPr>
-              <a:t>of attrs mutants fell back</a:t>
+              <a:t>net wall-clock reduction</a:t>
             </a:r>
             <a:endParaRPr lang="en-US" sz="1200" dirty="0"/>
           </a:p>
@@ -6935,7 +6935,7 @@
                 <a:ea typeface="Calibri" pitchFamily="34" charset="-122"/>
                 <a:cs typeface="Calibri" pitchFamily="34" charset="-120"/>
               </a:rPr>
-              <a:t>50% on scrapy — all IMPORT_TIME_LINE</a:t>
+              <a:t>attrs / scrapy, fallbacks included</a:t>
             </a:r>
             <a:endParaRPr lang="en-US" sz="1000" dirty="0"/>
           </a:p>
@@ -7032,7 +7032,7 @@
                 <a:ea typeface="Calibri" pitchFamily="34" charset="-122"/>
                 <a:cs typeface="Calibri" pitchFamily="34" charset="-120"/>
               </a:rPr>
-              <a:t>Zero misses is the result that matters. It is bought by giving up line-level selection on roughly 60% of changes — where tia is no faster than simply running everything. Both numbers are published; neither is an appendix.</a:t>
+              <a:t>Zero misses is the result that matters. It costs a fallback on ~60% of attrs changes, where tia runs everything. Even so, the net saving across all mutants is 46% on attrs and 48% on scrapy — inside the 40-70% the proposal set out to validate.</a:t>
             </a:r>
             <a:endParaRPr lang="en-US" sz="1200" dirty="0"/>
           </a:p>
@@ -7717,7 +7717,7 @@
         <p:spPr>
           <a:xfrm>
             <a:off x="5760720" y="2560320"/>
-            <a:ext cx="5760720" cy="3017520"/>
+            <a:ext cx="5760720" cy="2423160"/>
           </a:xfrm>
           <a:prstGeom prst="rect">
             <a:avLst/>
@@ -7731,16 +7731,16 @@
           <a:p>
             <a:pPr marL="342900" indent="-342900">
               <a:lnSpc>
-                <a:spcPts val="1900"/>
+                <a:spcPts val="1800"/>
               </a:lnSpc>
               <a:spcAft>
-                <a:spcPts val="900"/>
+                <a:spcPts val="800"/>
               </a:spcAft>
               <a:buSzPct val="100000"/>
               <a:buChar char="•"/>
             </a:pPr>
             <a:r>
-              <a:rPr lang="en-US" sz="1250" dirty="0">
+              <a:rPr lang="en-US" sz="1200" dirty="0">
                 <a:solidFill>
                   <a:srgbClr val="17232F"/>
                 </a:solidFill>
@@ -7750,21 +7750,21 @@
               </a:rPr>
               <a:t>On roughly 60% of changes to attrs, tia runs the whole suite — it is safe, and it is no faster than not using it.</a:t>
             </a:r>
-            <a:endParaRPr lang="en-US" sz="1250" dirty="0"/>
+            <a:endParaRPr lang="en-US" sz="1200" dirty="0"/>
           </a:p>
           <a:p>
             <a:pPr marL="342900" indent="-342900">
               <a:lnSpc>
-                <a:spcPts val="1900"/>
+                <a:spcPts val="1800"/>
               </a:lnSpc>
               <a:spcAft>
-                <a:spcPts val="900"/>
+                <a:spcPts val="800"/>
               </a:spcAft>
               <a:buSzPct val="100000"/>
               <a:buChar char="•"/>
             </a:pPr>
             <a:r>
-              <a:rPr lang="en-US" sz="1250" dirty="0">
+              <a:rPr lang="en-US" sz="1200" dirty="0">
                 <a:solidFill>
                   <a:srgbClr val="17232F"/>
                 </a:solidFill>
@@ -7774,21 +7774,21 @@
               </a:rPr>
               <a:t>Every one of those fallbacks is IMPORT_TIME_LINE: a changed line that also ran during import, which coverage cannot attribute to any test.</a:t>
             </a:r>
-            <a:endParaRPr lang="en-US" sz="1250" dirty="0"/>
+            <a:endParaRPr lang="en-US" sz="1200" dirty="0"/>
           </a:p>
           <a:p>
             <a:pPr marL="342900" indent="-342900">
               <a:lnSpc>
-                <a:spcPts val="1900"/>
+                <a:spcPts val="1800"/>
               </a:lnSpc>
               <a:spcAft>
-                <a:spcPts val="900"/>
+                <a:spcPts val="800"/>
               </a:spcAft>
               <a:buSzPct val="100000"/>
               <a:buChar char="•"/>
             </a:pPr>
             <a:r>
-              <a:rPr lang="en-US" sz="1250" dirty="0">
+              <a:rPr lang="en-US" sz="1200" dirty="0">
                 <a:solidFill>
                   <a:srgbClr val="17232F"/>
                 </a:solidFill>
@@ -7798,21 +7798,21 @@
               </a:rPr>
               <a:t>This is not a bug to hide. It is the measured price of the rule that removed our only known miss.</a:t>
             </a:r>
-            <a:endParaRPr lang="en-US" sz="1250" dirty="0"/>
+            <a:endParaRPr lang="en-US" sz="1200" dirty="0"/>
           </a:p>
           <a:p>
             <a:pPr marL="342900" indent="-342900">
               <a:lnSpc>
-                <a:spcPts val="1900"/>
+                <a:spcPts val="1800"/>
               </a:lnSpc>
               <a:spcAft>
-                <a:spcPts val="900"/>
+                <a:spcPts val="800"/>
               </a:spcAft>
               <a:buSzPct val="100000"/>
               <a:buChar char="•"/>
             </a:pPr>
             <a:r>
-              <a:rPr lang="en-US" sz="1250" dirty="0">
+              <a:rPr lang="en-US" sz="1200" dirty="0">
                 <a:solidFill>
                   <a:srgbClr val="17232F"/>
                 </a:solidFill>
@@ -7820,9 +7820,114 @@
                 <a:ea typeface="Calibri" pitchFamily="34" charset="-122"/>
                 <a:cs typeface="Calibri" pitchFamily="34" charset="-120"/>
               </a:rPr>
-              <a:t>It also reframes Phase 2: the import graph is not an enhancement, it is what makes the safe version worth running. It can name the modules that imported a file and select their tests, instead of surrendering to the full suite.</a:t>
+              <a:t>It reframes Phase 2: the import graph is not an enhancement, it is what makes the safe version worth running.</a:t>
             </a:r>
-            <a:endParaRPr lang="en-US" sz="1250" dirty="0"/>
+            <a:endParaRPr lang="en-US" sz="1200" dirty="0"/>
+          </a:p>
+        </p:txBody>
+      </p:sp>
+      <p:sp>
+        <p:nvSpPr>
+          <p:cNvPr id="8" name="Shape 5"/>
+          <p:cNvSpPr/>
+          <p:nvPr/>
+        </p:nvSpPr>
+        <p:spPr>
+          <a:xfrm>
+            <a:off x="5760720" y="5138928"/>
+            <a:ext cx="5760720" cy="960120"/>
+          </a:xfrm>
+          <a:prstGeom prst="roundRect">
+            <a:avLst>
+              <a:gd name="adj" fmla="val 7619"/>
+            </a:avLst>
+          </a:prstGeom>
+          <a:solidFill>
+            <a:srgbClr val="17232F"/>
+          </a:solidFill>
+          <a:ln w="12700">
+            <a:solidFill>
+              <a:srgbClr val="333333"/>
+            </a:solidFill>
+            <a:prstDash val="solid"/>
+          </a:ln>
+        </p:spPr>
+      </p:sp>
+      <p:sp>
+        <p:nvSpPr>
+          <p:cNvPr id="9" name="Text 6"/>
+          <p:cNvSpPr txBox="1"/>
+          <p:nvPr/>
+        </p:nvSpPr>
+        <p:spPr>
+          <a:xfrm>
+            <a:off x="6035040" y="5285232"/>
+            <a:ext cx="5303520" cy="320040"/>
+          </a:xfrm>
+          <a:prstGeom prst="rect">
+            <a:avLst/>
+          </a:prstGeom>
+          <a:noFill/>
+          <a:ln/>
+        </p:spPr>
+        <p:txBody>
+          <a:bodyPr wrap="square" lIns="0" tIns="0" rIns="0" bIns="0" rtlCol="0" anchor="ctr"/>
+          <a:lstStyle/>
+          <a:p>
+            <a:pPr indent="0" marL="0">
+              <a:buNone/>
+            </a:pPr>
+            <a:r>
+              <a:rPr lang="en-US" sz="1500" b="1" dirty="0">
+                <a:solidFill>
+                  <a:srgbClr val="FFFFFF"/>
+                </a:solidFill>
+                <a:latin typeface="Cambria" pitchFamily="34" charset="0"/>
+                <a:ea typeface="Cambria" pitchFamily="34" charset="-122"/>
+                <a:cs typeface="Cambria" pitchFamily="34" charset="-120"/>
+              </a:rPr>
+              <a:t>Net of every fallback: 46% faster on attrs, 48% on scrapy.</a:t>
+            </a:r>
+            <a:endParaRPr lang="en-US" sz="1500" dirty="0"/>
+          </a:p>
+        </p:txBody>
+      </p:sp>
+      <p:sp>
+        <p:nvSpPr>
+          <p:cNvPr id="10" name="Text 7"/>
+          <p:cNvSpPr txBox="1"/>
+          <p:nvPr/>
+        </p:nvSpPr>
+        <p:spPr>
+          <a:xfrm>
+            <a:off x="6035040" y="5614416"/>
+            <a:ext cx="5303520" cy="320040"/>
+          </a:xfrm>
+          <a:prstGeom prst="rect">
+            <a:avLst/>
+          </a:prstGeom>
+          <a:noFill/>
+          <a:ln/>
+        </p:spPr>
+        <p:txBody>
+          <a:bodyPr wrap="square" lIns="0" tIns="0" rIns="0" bIns="0" rtlCol="0" anchor="ctr"/>
+          <a:lstStyle/>
+          <a:p>
+            <a:pPr indent="0" marL="0">
+              <a:buNone/>
+            </a:pPr>
+            <a:r>
+              <a:rPr lang="en-US" sz="1200" dirty="0">
+                <a:solidFill>
+                  <a:srgbClr val="AFC0CE"/>
+                </a:solidFill>
+                <a:latin typeface="Calibri" pitchFamily="34" charset="0"/>
+                <a:ea typeface="Calibri" pitchFamily="34" charset="-122"/>
+                <a:cs typeface="Calibri" pitchFamily="34" charset="-120"/>
+              </a:rPr>
+              <a:t>The proposal set out to validate a 40-70% range. Both land inside it.</a:t>
+            </a:r>
+            <a:endParaRPr lang="en-US" sz="1200" dirty="0"/>
           </a:p>
         </p:txBody>
       </p:sp>

</xml_diff>